<commit_message>
feat: complete normative logic system & UI/UX spec implementation with stance gating, non-stance handling, and test suite
</commit_message>
<xml_diff>
--- a/Echo_Chamber_Breaker_Pitch_Deck.pptx
+++ b/Echo_Chamber_Breaker_Pitch_Deck.pptx
@@ -4361,7 +4361,13 @@
       </p:sp>
       <p:sp>
         <p:nvSpPr>
-          <p:cNvPr id="13" name="Text 11"/>
+          <p:cNvPr id="13" name="Text 11">
+            <a:extLst>
+              <a:ext uri="{FF2B5EF4-FFF2-40B4-BE49-F238E27FC236}">
+                <a16:creationId xmlns:a16="http://schemas.microsoft.com/office/drawing/2014/main" id="{67D437AD-F977-4ED2-BDC6-9D412391B2E4}"/>
+              </a:ext>
+            </a:extLst>
+          </p:cNvPr>
           <p:cNvSpPr/>
           <p:nvPr/>
         </p:nvSpPr>
@@ -4392,7 +4398,7 @@
                 <a:ea typeface="Calibri" pitchFamily="34" charset="-122"/>
                 <a:cs typeface="Calibri" pitchFamily="34" charset="-120"/>
               </a:rPr>
-              <a:t>Alexa+ (or web simulator) calls real MCP tools</a:t>
+              <a:t>Nine real MCP tools, called by Alexa+ or the web simulator</a:t>
             </a:r>
             <a:endParaRPr lang="en-US" sz="1800" dirty="0"/>
           </a:p>
@@ -4400,14 +4406,20 @@
       </p:sp>
       <p:sp>
         <p:nvSpPr>
-          <p:cNvPr id="14" name="Shape 12"/>
-          <p:cNvSpPr/>
-          <p:nvPr/>
-        </p:nvSpPr>
-        <p:spPr>
-          <a:xfrm>
-            <a:off x="548640" y="1645920"/>
-            <a:ext cx="5394960" cy="1143000"/>
+          <p:cNvPr id="14" name="Shape 12">
+            <a:extLst>
+              <a:ext uri="{FF2B5EF4-FFF2-40B4-BE49-F238E27FC236}">
+                <a16:creationId xmlns:a16="http://schemas.microsoft.com/office/drawing/2014/main" id="{5CB24F52-8806-4FE3-8AD5-5F14DEFA46F2}"/>
+              </a:ext>
+            </a:extLst>
+          </p:cNvPr>
+          <p:cNvSpPr/>
+          <p:nvPr/>
+        </p:nvSpPr>
+        <p:spPr>
+          <a:xfrm>
+            <a:off x="552450" y="1647825"/>
+            <a:ext cx="3571875" cy="1143000"/>
           </a:xfrm>
           <a:prstGeom prst="roundRect">
             <a:avLst>
@@ -4422,14 +4434,20 @@
       </p:sp>
       <p:sp>
         <p:nvSpPr>
-          <p:cNvPr id="15" name="Text 13"/>
-          <p:cNvSpPr/>
-          <p:nvPr/>
-        </p:nvSpPr>
-        <p:spPr>
-          <a:xfrm>
-            <a:off x="777240" y="1874520"/>
-            <a:ext cx="4937760" cy="320040"/>
+          <p:cNvPr id="15" name="Text 13">
+            <a:extLst>
+              <a:ext uri="{FF2B5EF4-FFF2-40B4-BE49-F238E27FC236}">
+                <a16:creationId xmlns:a16="http://schemas.microsoft.com/office/drawing/2014/main" id="{81000BD7-33D7-48EF-9A39-2BCD8C041C0F}"/>
+              </a:ext>
+            </a:extLst>
+          </p:cNvPr>
+          <p:cNvSpPr/>
+          <p:nvPr/>
+        </p:nvSpPr>
+        <p:spPr>
+          <a:xfrm>
+            <a:off x="781050" y="1876425"/>
+            <a:ext cx="3114675" cy="323850"/>
           </a:xfrm>
           <a:prstGeom prst="rect">
             <a:avLst/>
@@ -4461,14 +4479,20 @@
       </p:sp>
       <p:sp>
         <p:nvSpPr>
-          <p:cNvPr id="16" name="Text 14"/>
-          <p:cNvSpPr/>
-          <p:nvPr/>
-        </p:nvSpPr>
-        <p:spPr>
-          <a:xfrm>
-            <a:off x="777240" y="2286000"/>
-            <a:ext cx="4937760" cy="320040"/>
+          <p:cNvPr id="16" name="Text 14">
+            <a:extLst>
+              <a:ext uri="{FF2B5EF4-FFF2-40B4-BE49-F238E27FC236}">
+                <a16:creationId xmlns:a16="http://schemas.microsoft.com/office/drawing/2014/main" id="{EA47BE69-B182-4A29-BD9C-B717A1456BC8}"/>
+              </a:ext>
+            </a:extLst>
+          </p:cNvPr>
+          <p:cNvSpPr/>
+          <p:nvPr/>
+        </p:nvSpPr>
+        <p:spPr>
+          <a:xfrm>
+            <a:off x="781050" y="2286000"/>
+            <a:ext cx="3114675" cy="323850"/>
           </a:xfrm>
           <a:prstGeom prst="rect">
             <a:avLst/>
@@ -4492,7 +4516,7 @@
                 <a:ea typeface="Calibri" pitchFamily="34" charset="-122"/>
                 <a:cs typeface="Calibri" pitchFamily="34" charset="-120"/>
               </a:rPr>
-              <a:t>Detect strength + blind spots</a:t>
+              <a:t>Detect stance, emotions, blind spots</a:t>
             </a:r>
             <a:endParaRPr lang="en-US" sz="1400" dirty="0"/>
           </a:p>
@@ -4500,14 +4524,20 @@
       </p:sp>
       <p:sp>
         <p:nvSpPr>
-          <p:cNvPr id="17" name="Shape 15"/>
-          <p:cNvSpPr/>
-          <p:nvPr/>
-        </p:nvSpPr>
-        <p:spPr>
-          <a:xfrm>
-            <a:off x="548640" y="2971800"/>
-            <a:ext cx="5394960" cy="1143000"/>
+          <p:cNvPr id="17" name="Shape 15">
+            <a:extLst>
+              <a:ext uri="{FF2B5EF4-FFF2-40B4-BE49-F238E27FC236}">
+                <a16:creationId xmlns:a16="http://schemas.microsoft.com/office/drawing/2014/main" id="{DE474D34-A023-4578-93C8-49F3E7859095}"/>
+              </a:ext>
+            </a:extLst>
+          </p:cNvPr>
+          <p:cNvSpPr/>
+          <p:nvPr/>
+        </p:nvSpPr>
+        <p:spPr>
+          <a:xfrm>
+            <a:off x="4305300" y="1647825"/>
+            <a:ext cx="3571875" cy="1143000"/>
           </a:xfrm>
           <a:prstGeom prst="roundRect">
             <a:avLst>
@@ -4522,14 +4552,20 @@
       </p:sp>
       <p:sp>
         <p:nvSpPr>
-          <p:cNvPr id="18" name="Text 16"/>
-          <p:cNvSpPr/>
-          <p:nvPr/>
-        </p:nvSpPr>
-        <p:spPr>
-          <a:xfrm>
-            <a:off x="777240" y="3200400"/>
-            <a:ext cx="4937760" cy="320040"/>
+          <p:cNvPr id="18" name="Text 16">
+            <a:extLst>
+              <a:ext uri="{FF2B5EF4-FFF2-40B4-BE49-F238E27FC236}">
+                <a16:creationId xmlns:a16="http://schemas.microsoft.com/office/drawing/2014/main" id="{AB2156D5-4BFC-4925-B072-FADB5A2C021D}"/>
+              </a:ext>
+            </a:extLst>
+          </p:cNvPr>
+          <p:cNvSpPr/>
+          <p:nvPr/>
+        </p:nvSpPr>
+        <p:spPr>
+          <a:xfrm>
+            <a:off x="4533900" y="1876425"/>
+            <a:ext cx="3114675" cy="323850"/>
           </a:xfrm>
           <a:prstGeom prst="rect">
             <a:avLst/>
@@ -4561,14 +4597,20 @@
       </p:sp>
       <p:sp>
         <p:nvSpPr>
-          <p:cNvPr id="19" name="Text 17"/>
-          <p:cNvSpPr/>
-          <p:nvPr/>
-        </p:nvSpPr>
-        <p:spPr>
-          <a:xfrm>
-            <a:off x="777240" y="3611880"/>
-            <a:ext cx="4937760" cy="320040"/>
+          <p:cNvPr id="19" name="Text 17">
+            <a:extLst>
+              <a:ext uri="{FF2B5EF4-FFF2-40B4-BE49-F238E27FC236}">
+                <a16:creationId xmlns:a16="http://schemas.microsoft.com/office/drawing/2014/main" id="{CAFB3F94-DAA8-401F-B0E1-749F18E4914B}"/>
+              </a:ext>
+            </a:extLst>
+          </p:cNvPr>
+          <p:cNvSpPr/>
+          <p:nvPr/>
+        </p:nvSpPr>
+        <p:spPr>
+          <a:xfrm>
+            <a:off x="4533900" y="2286000"/>
+            <a:ext cx="3114675" cy="323850"/>
           </a:xfrm>
           <a:prstGeom prst="rect">
             <a:avLst/>
@@ -4592,7 +4634,7 @@
                 <a:ea typeface="Calibri" pitchFamily="34" charset="-122"/>
                 <a:cs typeface="Calibri" pitchFamily="34" charset="-120"/>
               </a:rPr>
-              <a:t>Generate strongest opposing case</a:t>
+              <a:t>Strongest charitable counter-case</a:t>
             </a:r>
             <a:endParaRPr lang="en-US" sz="1400" dirty="0"/>
           </a:p>
@@ -4600,14 +4642,20 @@
       </p:sp>
       <p:sp>
         <p:nvSpPr>
-          <p:cNvPr id="20" name="Shape 18"/>
-          <p:cNvSpPr/>
-          <p:nvPr/>
-        </p:nvSpPr>
-        <p:spPr>
-          <a:xfrm>
-            <a:off x="548640" y="4297680"/>
-            <a:ext cx="5394960" cy="1143000"/>
+          <p:cNvPr id="20" name="Shape 18">
+            <a:extLst>
+              <a:ext uri="{FF2B5EF4-FFF2-40B4-BE49-F238E27FC236}">
+                <a16:creationId xmlns:a16="http://schemas.microsoft.com/office/drawing/2014/main" id="{B088C75D-15D9-4721-8F56-694114C2D0E7}"/>
+              </a:ext>
+            </a:extLst>
+          </p:cNvPr>
+          <p:cNvSpPr/>
+          <p:nvPr/>
+        </p:nvSpPr>
+        <p:spPr>
+          <a:xfrm>
+            <a:off x="8058150" y="1647825"/>
+            <a:ext cx="3571875" cy="1143000"/>
           </a:xfrm>
           <a:prstGeom prst="roundRect">
             <a:avLst>
@@ -4622,14 +4670,20 @@
       </p:sp>
       <p:sp>
         <p:nvSpPr>
-          <p:cNvPr id="21" name="Text 19"/>
-          <p:cNvSpPr/>
-          <p:nvPr/>
-        </p:nvSpPr>
-        <p:spPr>
-          <a:xfrm>
-            <a:off x="777240" y="4526280"/>
-            <a:ext cx="4937760" cy="320040"/>
+          <p:cNvPr id="21" name="Text 19">
+            <a:extLst>
+              <a:ext uri="{FF2B5EF4-FFF2-40B4-BE49-F238E27FC236}">
+                <a16:creationId xmlns:a16="http://schemas.microsoft.com/office/drawing/2014/main" id="{DE078B40-709F-4E0C-A60F-C707E0E071F8}"/>
+              </a:ext>
+            </a:extLst>
+          </p:cNvPr>
+          <p:cNvSpPr/>
+          <p:nvPr/>
+        </p:nvSpPr>
+        <p:spPr>
+          <a:xfrm>
+            <a:off x="8286750" y="1876425"/>
+            <a:ext cx="3114675" cy="323850"/>
           </a:xfrm>
           <a:prstGeom prst="rect">
             <a:avLst/>
@@ -4653,7 +4707,7 @@
                 <a:ea typeface="Consolas" pitchFamily="34" charset="-122"/>
                 <a:cs typeface="Consolas" pitchFamily="34" charset="-120"/>
               </a:rPr>
-              <a:t>start / continue_debate</a:t>
+              <a:t>record_engagement</a:t>
             </a:r>
             <a:endParaRPr lang="en-US" sz="1400" dirty="0"/>
           </a:p>
@@ -4661,14 +4715,20 @@
       </p:sp>
       <p:sp>
         <p:nvSpPr>
-          <p:cNvPr id="22" name="Text 20"/>
-          <p:cNvSpPr/>
-          <p:nvPr/>
-        </p:nvSpPr>
-        <p:spPr>
-          <a:xfrm>
-            <a:off x="777240" y="4937760"/>
-            <a:ext cx="4937760" cy="320040"/>
+          <p:cNvPr id="22" name="Text 20">
+            <a:extLst>
+              <a:ext uri="{FF2B5EF4-FFF2-40B4-BE49-F238E27FC236}">
+                <a16:creationId xmlns:a16="http://schemas.microsoft.com/office/drawing/2014/main" id="{ACB3E0A3-058C-4CAD-BC91-8BAECAE05F94}"/>
+              </a:ext>
+            </a:extLst>
+          </p:cNvPr>
+          <p:cNvSpPr/>
+          <p:nvPr/>
+        </p:nvSpPr>
+        <p:spPr>
+          <a:xfrm>
+            <a:off x="8286750" y="2286000"/>
+            <a:ext cx="3114675" cy="323850"/>
           </a:xfrm>
           <a:prstGeom prst="rect">
             <a:avLst/>
@@ -4692,7 +4752,7 @@
                 <a:ea typeface="Calibri" pitchFamily="34" charset="-122"/>
                 <a:cs typeface="Calibri" pitchFamily="34" charset="-120"/>
               </a:rPr>
-              <a:t>Multi-turn structured challenge</a:t>
+              <a:t>Did the user actually grapple?</a:t>
             </a:r>
             <a:endParaRPr lang="en-US" sz="1400" dirty="0"/>
           </a:p>
@@ -4700,14 +4760,20 @@
       </p:sp>
       <p:sp>
         <p:nvSpPr>
-          <p:cNvPr id="23" name="Shape 21"/>
-          <p:cNvSpPr/>
-          <p:nvPr/>
-        </p:nvSpPr>
-        <p:spPr>
-          <a:xfrm>
-            <a:off x="6217920" y="1645920"/>
-            <a:ext cx="5394960" cy="1143000"/>
+          <p:cNvPr id="23" name="Shape 21">
+            <a:extLst>
+              <a:ext uri="{FF2B5EF4-FFF2-40B4-BE49-F238E27FC236}">
+                <a16:creationId xmlns:a16="http://schemas.microsoft.com/office/drawing/2014/main" id="{C22357D5-8CCE-48D1-B698-C46EE910270A}"/>
+              </a:ext>
+            </a:extLst>
+          </p:cNvPr>
+          <p:cNvSpPr/>
+          <p:nvPr/>
+        </p:nvSpPr>
+        <p:spPr>
+          <a:xfrm>
+            <a:off x="552450" y="2971800"/>
+            <a:ext cx="3571875" cy="1143000"/>
           </a:xfrm>
           <a:prstGeom prst="roundRect">
             <a:avLst>
@@ -4722,14 +4788,20 @@
       </p:sp>
       <p:sp>
         <p:nvSpPr>
-          <p:cNvPr id="24" name="Text 22"/>
-          <p:cNvSpPr/>
-          <p:nvPr/>
-        </p:nvSpPr>
-        <p:spPr>
-          <a:xfrm>
-            <a:off x="6446520" y="1874520"/>
-            <a:ext cx="4937760" cy="320040"/>
+          <p:cNvPr id="24" name="Text 22">
+            <a:extLst>
+              <a:ext uri="{FF2B5EF4-FFF2-40B4-BE49-F238E27FC236}">
+                <a16:creationId xmlns:a16="http://schemas.microsoft.com/office/drawing/2014/main" id="{6A9A126E-1079-4192-8501-284020D79DF7}"/>
+              </a:ext>
+            </a:extLst>
+          </p:cNvPr>
+          <p:cNvSpPr/>
+          <p:nvPr/>
+        </p:nvSpPr>
+        <p:spPr>
+          <a:xfrm>
+            <a:off x="781050" y="3199800"/>
+            <a:ext cx="3114675" cy="323850"/>
           </a:xfrm>
           <a:prstGeom prst="rect">
             <a:avLst/>
@@ -4753,7 +4825,7 @@
                 <a:ea typeface="Consolas" pitchFamily="34" charset="-122"/>
                 <a:cs typeface="Consolas" pitchFamily="34" charset="-120"/>
               </a:rPr>
-              <a:t>record_engagement</a:t>
+              <a:t>start_debate</a:t>
             </a:r>
             <a:endParaRPr lang="en-US" sz="1400" dirty="0"/>
           </a:p>
@@ -4761,14 +4833,20 @@
       </p:sp>
       <p:sp>
         <p:nvSpPr>
-          <p:cNvPr id="25" name="Text 23"/>
-          <p:cNvSpPr/>
-          <p:nvPr/>
-        </p:nvSpPr>
-        <p:spPr>
-          <a:xfrm>
-            <a:off x="6446520" y="2286000"/>
-            <a:ext cx="4937760" cy="320040"/>
+          <p:cNvPr id="25" name="Text 23">
+            <a:extLst>
+              <a:ext uri="{FF2B5EF4-FFF2-40B4-BE49-F238E27FC236}">
+                <a16:creationId xmlns:a16="http://schemas.microsoft.com/office/drawing/2014/main" id="{45F843C1-1B19-4103-89E5-E0F5FF468EA5}"/>
+              </a:ext>
+            </a:extLst>
+          </p:cNvPr>
+          <p:cNvSpPr/>
+          <p:nvPr/>
+        </p:nvSpPr>
+        <p:spPr>
+          <a:xfrm>
+            <a:off x="781050" y="3609975"/>
+            <a:ext cx="3114675" cy="323850"/>
           </a:xfrm>
           <a:prstGeom prst="rect">
             <a:avLst/>
@@ -4792,7 +4870,7 @@
                 <a:ea typeface="Calibri" pitchFamily="34" charset="-122"/>
                 <a:cs typeface="Calibri" pitchFamily="34" charset="-120"/>
               </a:rPr>
-              <a:t>Did the user actually grapple?</a:t>
+              <a:t>Open a bounded, timed exchange</a:t>
             </a:r>
             <a:endParaRPr lang="en-US" sz="1400" dirty="0"/>
           </a:p>
@@ -4800,14 +4878,20 @@
       </p:sp>
       <p:sp>
         <p:nvSpPr>
-          <p:cNvPr id="26" name="Shape 24"/>
-          <p:cNvSpPr/>
-          <p:nvPr/>
-        </p:nvSpPr>
-        <p:spPr>
-          <a:xfrm>
-            <a:off x="6217920" y="2971800"/>
-            <a:ext cx="5394960" cy="1143000"/>
+          <p:cNvPr id="26" name="Shape 24">
+            <a:extLst>
+              <a:ext uri="{FF2B5EF4-FFF2-40B4-BE49-F238E27FC236}">
+                <a16:creationId xmlns:a16="http://schemas.microsoft.com/office/drawing/2014/main" id="{8160FD48-FDF1-4119-AC29-9A57D8C0496F}"/>
+              </a:ext>
+            </a:extLst>
+          </p:cNvPr>
+          <p:cNvSpPr/>
+          <p:nvPr/>
+        </p:nvSpPr>
+        <p:spPr>
+          <a:xfrm>
+            <a:off x="4305300" y="2971800"/>
+            <a:ext cx="3571875" cy="1143000"/>
           </a:xfrm>
           <a:prstGeom prst="roundRect">
             <a:avLst>
@@ -4822,14 +4906,20 @@
       </p:sp>
       <p:sp>
         <p:nvSpPr>
-          <p:cNvPr id="27" name="Text 25"/>
-          <p:cNvSpPr/>
-          <p:nvPr/>
-        </p:nvSpPr>
-        <p:spPr>
-          <a:xfrm>
-            <a:off x="6446520" y="3200400"/>
-            <a:ext cx="4937760" cy="320040"/>
+          <p:cNvPr id="27" name="Text 25">
+            <a:extLst>
+              <a:ext uri="{FF2B5EF4-FFF2-40B4-BE49-F238E27FC236}">
+                <a16:creationId xmlns:a16="http://schemas.microsoft.com/office/drawing/2014/main" id="{02E5F1FC-A9FA-40B2-A934-706E2F3143E3}"/>
+              </a:ext>
+            </a:extLst>
+          </p:cNvPr>
+          <p:cNvSpPr/>
+          <p:nvPr/>
+        </p:nvSpPr>
+        <p:spPr>
+          <a:xfrm>
+            <a:off x="4533900" y="3199800"/>
+            <a:ext cx="3114675" cy="323850"/>
           </a:xfrm>
           <a:prstGeom prst="rect">
             <a:avLst/>
@@ -4853,7 +4943,7 @@
                 <a:ea typeface="Consolas" pitchFamily="34" charset="-122"/>
                 <a:cs typeface="Consolas" pitchFamily="34" charset="-120"/>
               </a:rPr>
-              <a:t>honesty_report</a:t>
+              <a:t>continue_debate</a:t>
             </a:r>
             <a:endParaRPr lang="en-US" sz="1400" dirty="0"/>
           </a:p>
@@ -4861,14 +4951,20 @@
       </p:sp>
       <p:sp>
         <p:nvSpPr>
-          <p:cNvPr id="28" name="Text 26"/>
-          <p:cNvSpPr/>
-          <p:nvPr/>
-        </p:nvSpPr>
-        <p:spPr>
-          <a:xfrm>
-            <a:off x="6446520" y="3611880"/>
-            <a:ext cx="4937760" cy="320040"/>
+          <p:cNvPr id="28" name="Text 26">
+            <a:extLst>
+              <a:ext uri="{FF2B5EF4-FFF2-40B4-BE49-F238E27FC236}">
+                <a16:creationId xmlns:a16="http://schemas.microsoft.com/office/drawing/2014/main" id="{50CDF49F-6A00-4585-8DF4-5DE9EBF998E7}"/>
+              </a:ext>
+            </a:extLst>
+          </p:cNvPr>
+          <p:cNvSpPr/>
+          <p:nvPr/>
+        </p:nvSpPr>
+        <p:spPr>
+          <a:xfrm>
+            <a:off x="4533900" y="3609975"/>
+            <a:ext cx="3114675" cy="323850"/>
           </a:xfrm>
           <a:prstGeom prst="rect">
             <a:avLst/>
@@ -4892,7 +4988,7 @@
                 <a:ea typeface="Calibri" pitchFamily="34" charset="-122"/>
                 <a:cs typeface="Calibri" pitchFamily="34" charset="-120"/>
               </a:rPr>
-              <a:t>Score + trend + history</a:t>
+              <a:t>One move, graded on effort</a:t>
             </a:r>
             <a:endParaRPr lang="en-US" sz="1400" dirty="0"/>
           </a:p>
@@ -4900,14 +4996,20 @@
       </p:sp>
       <p:sp>
         <p:nvSpPr>
-          <p:cNvPr id="29" name="Shape 27"/>
-          <p:cNvSpPr/>
-          <p:nvPr/>
-        </p:nvSpPr>
-        <p:spPr>
-          <a:xfrm>
-            <a:off x="6217920" y="4297680"/>
-            <a:ext cx="5394960" cy="1143000"/>
+          <p:cNvPr id="29" name="Shape 27">
+            <a:extLst>
+              <a:ext uri="{FF2B5EF4-FFF2-40B4-BE49-F238E27FC236}">
+                <a16:creationId xmlns:a16="http://schemas.microsoft.com/office/drawing/2014/main" id="{FC14DCEE-1642-4CA1-9C6A-8080CBC0B8CF}"/>
+              </a:ext>
+            </a:extLst>
+          </p:cNvPr>
+          <p:cNvSpPr/>
+          <p:nvPr/>
+        </p:nvSpPr>
+        <p:spPr>
+          <a:xfrm>
+            <a:off x="8058150" y="2971800"/>
+            <a:ext cx="3571875" cy="1143000"/>
           </a:xfrm>
           <a:prstGeom prst="roundRect">
             <a:avLst>
@@ -4922,14 +5024,20 @@
       </p:sp>
       <p:sp>
         <p:nvSpPr>
-          <p:cNvPr id="30" name="Text 28"/>
-          <p:cNvSpPr/>
-          <p:nvPr/>
-        </p:nvSpPr>
-        <p:spPr>
-          <a:xfrm>
-            <a:off x="6446520" y="4526280"/>
-            <a:ext cx="4937760" cy="320040"/>
+          <p:cNvPr id="30" name="Text 28">
+            <a:extLst>
+              <a:ext uri="{FF2B5EF4-FFF2-40B4-BE49-F238E27FC236}">
+                <a16:creationId xmlns:a16="http://schemas.microsoft.com/office/drawing/2014/main" id="{D3632BD9-9672-4C2A-BA47-4A3EA06D2C5A}"/>
+              </a:ext>
+            </a:extLst>
+          </p:cNvPr>
+          <p:cNvSpPr/>
+          <p:nvPr/>
+        </p:nvSpPr>
+        <p:spPr>
+          <a:xfrm>
+            <a:off x="8286750" y="3199800"/>
+            <a:ext cx="3114675" cy="323850"/>
           </a:xfrm>
           <a:prstGeom prst="rect">
             <a:avLst/>
@@ -4953,7 +5061,7 @@
                 <a:ea typeface="Consolas" pitchFamily="34" charset="-122"/>
                 <a:cs typeface="Consolas" pitchFamily="34" charset="-120"/>
               </a:rPr>
-              <a:t>challenge_me</a:t>
+              <a:t>end_debate</a:t>
             </a:r>
             <a:endParaRPr lang="en-US" sz="1400" dirty="0"/>
           </a:p>
@@ -4961,14 +5069,20 @@
       </p:sp>
       <p:sp>
         <p:nvSpPr>
-          <p:cNvPr id="31" name="Text 29"/>
-          <p:cNvSpPr/>
-          <p:nvPr/>
-        </p:nvSpPr>
-        <p:spPr>
-          <a:xfrm>
-            <a:off x="6446520" y="4937760"/>
-            <a:ext cx="4937760" cy="320040"/>
+          <p:cNvPr id="31" name="Text 29">
+            <a:extLst>
+              <a:ext uri="{FF2B5EF4-FFF2-40B4-BE49-F238E27FC236}">
+                <a16:creationId xmlns:a16="http://schemas.microsoft.com/office/drawing/2014/main" id="{E4878826-A783-4547-953A-652E2CEC311D}"/>
+              </a:ext>
+            </a:extLst>
+          </p:cNvPr>
+          <p:cNvSpPr/>
+          <p:nvPr/>
+        </p:nvSpPr>
+        <p:spPr>
+          <a:xfrm>
+            <a:off x="8286750" y="3609975"/>
+            <a:ext cx="3114675" cy="323850"/>
           </a:xfrm>
           <a:prstGeom prst="rect">
             <a:avLst/>
@@ -4992,9 +5106,336 @@
                 <a:ea typeface="Calibri" pitchFamily="34" charset="-122"/>
                 <a:cs typeface="Calibri" pitchFamily="34" charset="-120"/>
               </a:rPr>
-              <a:t>Proactive intellectual friction</a:t>
+              <a:t>Bank the completion, close</a:t>
             </a:r>
             <a:endParaRPr lang="en-US" sz="1400" dirty="0"/>
+          </a:p>
+        </p:txBody>
+      </p:sp>
+      <p:sp>
+        <p:nvSpPr>
+          <p:cNvPr id="32" name="Shape 32">
+            <a:extLst>
+              <a:ext uri="{FF2B5EF4-FFF2-40B4-BE49-F238E27FC236}">
+                <a16:creationId xmlns:a16="http://schemas.microsoft.com/office/drawing/2014/main" id="{DFC4E9D7-647C-45F9-8B21-2E499F78EDC9}"/>
+              </a:ext>
+            </a:extLst>
+          </p:cNvPr>
+          <p:cNvSpPr/>
+          <p:nvPr/>
+        </p:nvSpPr>
+        <p:spPr>
+          <a:xfrm>
+            <a:off x="552450" y="4295775"/>
+            <a:ext cx="3571875" cy="1143000"/>
+          </a:xfrm>
+          <a:prstGeom prst="rect">
+            <a:avLst/>
+          </a:prstGeom>
+          <a:solidFill>
+            <a:srgbClr val="161C19"/>
+          </a:solidFill>
+        </p:spPr>
+        <p:txBody>
+          <a:bodyPr wrap="square" rtlCol="0"/>
+          <a:lstStyle/>
+          <a:p>
+            <a:r>
+              <a:rPr/>
+              <a:t/>
+            </a:r>
+          </a:p>
+        </p:txBody>
+      </p:sp>
+      <p:sp>
+        <p:nvSpPr>
+          <p:cNvPr id="33" name="TextBox 33">
+            <a:extLst>
+              <a:ext uri="{FF2B5EF4-FFF2-40B4-BE49-F238E27FC236}">
+                <a16:creationId xmlns:a16="http://schemas.microsoft.com/office/drawing/2014/main" id="{AAF0FB7B-F4EF-4F5E-AE34-C671891FF509}"/>
+              </a:ext>
+            </a:extLst>
+          </p:cNvPr>
+          <p:cNvSpPr txBox="1"/>
+          <p:nvPr/>
+        </p:nvSpPr>
+        <p:spPr>
+          <a:xfrm>
+            <a:off x="781050" y="4524375"/>
+            <a:ext cx="3114675" cy="323850"/>
+          </a:xfrm>
+        </p:spPr>
+        <p:txBody>
+          <a:bodyPr wrap="square" rtlCol="0"/>
+          <a:lstStyle/>
+          <a:p>
+            <a:pPr algn="l"/>
+            <a:r>
+              <a:rPr sz="1400">
+                <a:solidFill>
+                  <a:srgbClr val="A8D95E"/>
+                </a:solidFill>
+                <a:latin typeface="Consolas"/>
+                <a:ea typeface="Consolas"/>
+                <a:cs typeface="Consolas"/>
+              </a:rPr>
+              <a:t>honesty_report</a:t>
+            </a:r>
+          </a:p>
+        </p:txBody>
+      </p:sp>
+      <p:sp>
+        <p:nvSpPr>
+          <p:cNvPr id="34" name="TextBox 34">
+            <a:extLst>
+              <a:ext uri="{FF2B5EF4-FFF2-40B4-BE49-F238E27FC236}">
+                <a16:creationId xmlns:a16="http://schemas.microsoft.com/office/drawing/2014/main" id="{9E9808F7-0E96-461B-BDDD-E8D57B16E3AE}"/>
+              </a:ext>
+            </a:extLst>
+          </p:cNvPr>
+          <p:cNvSpPr txBox="1"/>
+          <p:nvPr/>
+        </p:nvSpPr>
+        <p:spPr>
+          <a:xfrm>
+            <a:off x="781050" y="4933950"/>
+            <a:ext cx="3114675" cy="323850"/>
+          </a:xfrm>
+        </p:spPr>
+        <p:txBody>
+          <a:bodyPr wrap="square" rtlCol="0"/>
+          <a:lstStyle/>
+          <a:p>
+            <a:pPr algn="l"/>
+            <a:r>
+              <a:rPr sz="1400">
+                <a:solidFill>
+                  <a:srgbClr val="8A8F86"/>
+                </a:solidFill>
+                <a:latin typeface="Calibri"/>
+                <a:ea typeface="Calibri"/>
+                <a:cs typeface="Calibri"/>
+              </a:rPr>
+              <a:t>Score, movement, the events</a:t>
+            </a:r>
+          </a:p>
+        </p:txBody>
+      </p:sp>
+      <p:sp>
+        <p:nvSpPr>
+          <p:cNvPr id="35" name="Shape 35">
+            <a:extLst>
+              <a:ext uri="{FF2B5EF4-FFF2-40B4-BE49-F238E27FC236}">
+                <a16:creationId xmlns:a16="http://schemas.microsoft.com/office/drawing/2014/main" id="{F70801BB-871D-41CD-9F08-78BD7B6E55FE}"/>
+              </a:ext>
+            </a:extLst>
+          </p:cNvPr>
+          <p:cNvSpPr/>
+          <p:nvPr/>
+        </p:nvSpPr>
+        <p:spPr>
+          <a:xfrm>
+            <a:off x="4305300" y="4295775"/>
+            <a:ext cx="3571875" cy="1143000"/>
+          </a:xfrm>
+          <a:prstGeom prst="rect">
+            <a:avLst/>
+          </a:prstGeom>
+          <a:solidFill>
+            <a:srgbClr val="161C19"/>
+          </a:solidFill>
+        </p:spPr>
+        <p:txBody>
+          <a:bodyPr wrap="square" rtlCol="0"/>
+          <a:lstStyle/>
+          <a:p>
+            <a:r>
+              <a:rPr/>
+              <a:t/>
+            </a:r>
+          </a:p>
+        </p:txBody>
+      </p:sp>
+      <p:sp>
+        <p:nvSpPr>
+          <p:cNvPr id="36" name="TextBox 36">
+            <a:extLst>
+              <a:ext uri="{FF2B5EF4-FFF2-40B4-BE49-F238E27FC236}">
+                <a16:creationId xmlns:a16="http://schemas.microsoft.com/office/drawing/2014/main" id="{B8AC771D-FADA-469E-9C70-BF81A7510354}"/>
+              </a:ext>
+            </a:extLst>
+          </p:cNvPr>
+          <p:cNvSpPr txBox="1"/>
+          <p:nvPr/>
+        </p:nvSpPr>
+        <p:spPr>
+          <a:xfrm>
+            <a:off x="4533900" y="4524375"/>
+            <a:ext cx="3114675" cy="323850"/>
+          </a:xfrm>
+        </p:spPr>
+        <p:txBody>
+          <a:bodyPr wrap="square" rtlCol="0"/>
+          <a:lstStyle/>
+          <a:p>
+            <a:pPr algn="l"/>
+            <a:r>
+              <a:rPr sz="1400">
+                <a:solidFill>
+                  <a:srgbClr val="A8D95E"/>
+                </a:solidFill>
+                <a:latin typeface="Consolas"/>
+                <a:ea typeface="Consolas"/>
+                <a:cs typeface="Consolas"/>
+              </a:rPr>
+              <a:t>get_honesty_history</a:t>
+            </a:r>
+          </a:p>
+        </p:txBody>
+      </p:sp>
+      <p:sp>
+        <p:nvSpPr>
+          <p:cNvPr id="37" name="TextBox 37">
+            <a:extLst>
+              <a:ext uri="{FF2B5EF4-FFF2-40B4-BE49-F238E27FC236}">
+                <a16:creationId xmlns:a16="http://schemas.microsoft.com/office/drawing/2014/main" id="{3B52D49C-E553-4710-BB40-5C7D0B6AE920}"/>
+              </a:ext>
+            </a:extLst>
+          </p:cNvPr>
+          <p:cNvSpPr txBox="1"/>
+          <p:nvPr/>
+        </p:nvSpPr>
+        <p:spPr>
+          <a:xfrm>
+            <a:off x="4533900" y="4933950"/>
+            <a:ext cx="3114675" cy="323850"/>
+          </a:xfrm>
+        </p:spPr>
+        <p:txBody>
+          <a:bodyPr wrap="square" rtlCol="0"/>
+          <a:lstStyle/>
+          <a:p>
+            <a:pPr algn="l"/>
+            <a:r>
+              <a:rPr sz="1400">
+                <a:solidFill>
+                  <a:srgbClr val="8A8F86"/>
+                </a:solidFill>
+                <a:latin typeface="Calibri"/>
+                <a:ea typeface="Calibri"/>
+                <a:cs typeface="Calibri"/>
+              </a:rPr>
+              <a:t>Raw ledger, newest first</a:t>
+            </a:r>
+          </a:p>
+        </p:txBody>
+      </p:sp>
+      <p:sp>
+        <p:nvSpPr>
+          <p:cNvPr id="38" name="Shape 38">
+            <a:extLst>
+              <a:ext uri="{FF2B5EF4-FFF2-40B4-BE49-F238E27FC236}">
+                <a16:creationId xmlns:a16="http://schemas.microsoft.com/office/drawing/2014/main" id="{6568D9A7-34EA-4F1C-AE67-C11F920D8F16}"/>
+              </a:ext>
+            </a:extLst>
+          </p:cNvPr>
+          <p:cNvSpPr/>
+          <p:nvPr/>
+        </p:nvSpPr>
+        <p:spPr>
+          <a:xfrm>
+            <a:off x="8058150" y="4295775"/>
+            <a:ext cx="3571875" cy="1143000"/>
+          </a:xfrm>
+          <a:prstGeom prst="rect">
+            <a:avLst/>
+          </a:prstGeom>
+          <a:solidFill>
+            <a:srgbClr val="161C19"/>
+          </a:solidFill>
+        </p:spPr>
+        <p:txBody>
+          <a:bodyPr wrap="square" rtlCol="0"/>
+          <a:lstStyle/>
+          <a:p>
+            <a:r>
+              <a:rPr/>
+              <a:t/>
+            </a:r>
+          </a:p>
+        </p:txBody>
+      </p:sp>
+      <p:sp>
+        <p:nvSpPr>
+          <p:cNvPr id="39" name="TextBox 39">
+            <a:extLst>
+              <a:ext uri="{FF2B5EF4-FFF2-40B4-BE49-F238E27FC236}">
+                <a16:creationId xmlns:a16="http://schemas.microsoft.com/office/drawing/2014/main" id="{77280B84-01F4-4977-9ECB-601C66F55EC9}"/>
+              </a:ext>
+            </a:extLst>
+          </p:cNvPr>
+          <p:cNvSpPr txBox="1"/>
+          <p:nvPr/>
+        </p:nvSpPr>
+        <p:spPr>
+          <a:xfrm>
+            <a:off x="8286750" y="4524375"/>
+            <a:ext cx="3114675" cy="323850"/>
+          </a:xfrm>
+        </p:spPr>
+        <p:txBody>
+          <a:bodyPr wrap="square" rtlCol="0"/>
+          <a:lstStyle/>
+          <a:p>
+            <a:pPr algn="l"/>
+            <a:r>
+              <a:rPr sz="1400">
+                <a:solidFill>
+                  <a:srgbClr val="A8D95E"/>
+                </a:solidFill>
+                <a:latin typeface="Consolas"/>
+                <a:ea typeface="Consolas"/>
+                <a:cs typeface="Consolas"/>
+              </a:rPr>
+              <a:t>challenge_me</a:t>
+            </a:r>
+          </a:p>
+        </p:txBody>
+      </p:sp>
+      <p:sp>
+        <p:nvSpPr>
+          <p:cNvPr id="40" name="TextBox 40">
+            <a:extLst>
+              <a:ext uri="{FF2B5EF4-FFF2-40B4-BE49-F238E27FC236}">
+                <a16:creationId xmlns:a16="http://schemas.microsoft.com/office/drawing/2014/main" id="{412B8A7D-36A5-424E-9CE3-29A1321DC19C}"/>
+              </a:ext>
+            </a:extLst>
+          </p:cNvPr>
+          <p:cNvSpPr txBox="1"/>
+          <p:nvPr/>
+        </p:nvSpPr>
+        <p:spPr>
+          <a:xfrm>
+            <a:off x="8286750" y="4933950"/>
+            <a:ext cx="3114675" cy="323850"/>
+          </a:xfrm>
+        </p:spPr>
+        <p:txBody>
+          <a:bodyPr wrap="square" rtlCol="0"/>
+          <a:lstStyle/>
+          <a:p>
+            <a:pPr algn="l"/>
+            <a:r>
+              <a:rPr sz="1400">
+                <a:solidFill>
+                  <a:srgbClr val="8A8F86"/>
+                </a:solidFill>
+                <a:latin typeface="Calibri"/>
+                <a:ea typeface="Calibri"/>
+                <a:cs typeface="Calibri"/>
+              </a:rPr>
+              <a:t>What you left standing, again</a:t>
+            </a:r>
           </a:p>
         </p:txBody>
       </p:sp>
@@ -7571,7 +8012,13 @@
       </p:sp>
       <p:sp>
         <p:nvSpPr>
-          <p:cNvPr id="28" name="Text 26"/>
+          <p:cNvPr id="28" name="Text 26">
+            <a:extLst>
+              <a:ext uri="{FF2B5EF4-FFF2-40B4-BE49-F238E27FC236}">
+                <a16:creationId xmlns:a16="http://schemas.microsoft.com/office/drawing/2014/main" id="{B48C671A-4E98-4025-BBC8-B0E5F46D8B5E}"/>
+              </a:ext>
+            </a:extLst>
+          </p:cNvPr>
           <p:cNvSpPr/>
           <p:nvPr/>
         </p:nvSpPr>
@@ -7602,7 +8049,7 @@
                 <a:ea typeface="Calibri" pitchFamily="34" charset="-122"/>
                 <a:cs typeface="Calibri" pitchFamily="34" charset="-120"/>
               </a:rPr>
-              <a:t>honesty_report + optional challenge_me</a:t>
+              <a:t>start_debate → continue_debate → end_debate (turn budget enforced)</a:t>
             </a:r>
             <a:endParaRPr lang="en-US" sz="1500" dirty="0"/>
           </a:p>
@@ -7669,7 +8116,13 @@
       </p:sp>
       <p:sp>
         <p:nvSpPr>
-          <p:cNvPr id="31" name="Text 29"/>
+          <p:cNvPr id="31" name="Text 29">
+            <a:extLst>
+              <a:ext uri="{FF2B5EF4-FFF2-40B4-BE49-F238E27FC236}">
+                <a16:creationId xmlns:a16="http://schemas.microsoft.com/office/drawing/2014/main" id="{D7C21135-47DF-416D-B342-536B2B51CF81}"/>
+              </a:ext>
+            </a:extLst>
+          </p:cNvPr>
           <p:cNvSpPr/>
           <p:nvPr/>
         </p:nvSpPr>
@@ -7700,7 +8153,7 @@
                 <a:ea typeface="Calibri" pitchFamily="34" charset="-122"/>
                 <a:cs typeface="Calibri" pitchFamily="34" charset="-120"/>
               </a:rPr>
-              <a:t>Close on architecture + GitHub + friction log</a:t>
+              <a:t>honesty_report + get_honesty_history + challenge_me → close on the repo</a:t>
             </a:r>
             <a:endParaRPr lang="en-US" sz="1500" dirty="0"/>
           </a:p>
@@ -9733,4 +10186,299 @@
     </a:ext>
   </a:extLst>
 </a:theme>
+</file>
+
+<file path=ppt/theme/theme2.xml><?xml version="1.0" encoding="utf-8"?>
+<a:theme xmlns:a="http://schemas.openxmlformats.org/drawingml/2006/main" name="Office Theme">
+  <a:themeElements>
+    <a:clrScheme name="Office">
+      <a:dk1>
+        <a:sysClr val="windowText" lastClr="000000"/>
+      </a:dk1>
+      <a:lt1>
+        <a:sysClr val="window" lastClr="FFFFFF"/>
+      </a:lt1>
+      <a:dk2>
+        <a:srgbClr val="44546A"/>
+      </a:dk2>
+      <a:lt2>
+        <a:srgbClr val="E7E6E6"/>
+      </a:lt2>
+      <a:accent1>
+        <a:srgbClr val="4472C4"/>
+      </a:accent1>
+      <a:accent2>
+        <a:srgbClr val="ED7D31"/>
+      </a:accent2>
+      <a:accent3>
+        <a:srgbClr val="A5A5A5"/>
+      </a:accent3>
+      <a:accent4>
+        <a:srgbClr val="FFC000"/>
+      </a:accent4>
+      <a:accent5>
+        <a:srgbClr val="5B9BD5"/>
+      </a:accent5>
+      <a:accent6>
+        <a:srgbClr val="70AD47"/>
+      </a:accent6>
+      <a:hlink>
+        <a:srgbClr val="0563C1"/>
+      </a:hlink>
+      <a:folHlink>
+        <a:srgbClr val="954F72"/>
+      </a:folHlink>
+    </a:clrScheme>
+    <a:fontScheme name="Office">
+      <a:majorFont>
+        <a:latin typeface="Calibri Light" panose="020F0302020204030204"/>
+        <a:ea typeface=""/>
+        <a:cs typeface=""/>
+        <a:font script="Jpan" typeface="游ゴシック Light"/>
+        <a:font script="Hang" typeface="맑은 고딕"/>
+        <a:font script="Hans" typeface="等线 Light"/>
+        <a:font script="Hant" typeface="新細明體"/>
+        <a:font script="Arab" typeface="Times New Roman"/>
+        <a:font script="Hebr" typeface="Times New Roman"/>
+        <a:font script="Thai" typeface="Angsana New"/>
+        <a:font script="Ethi" typeface="Nyala"/>
+        <a:font script="Beng" typeface="Vrinda"/>
+        <a:font script="Gujr" typeface="Shruti"/>
+        <a:font script="Khmr" typeface="MoolBoran"/>
+        <a:font script="Knda" typeface="Tunga"/>
+        <a:font script="Guru" typeface="Raavi"/>
+        <a:font script="Cans" typeface="Euphemia"/>
+        <a:font script="Cher" typeface="Plantagenet Cherokee"/>
+        <a:font script="Yiii" typeface="Microsoft Yi Baiti"/>
+        <a:font script="Tibt" typeface="Microsoft Himalaya"/>
+        <a:font script="Thaa" typeface="MV Boli"/>
+        <a:font script="Deva" typeface="Mangal"/>
+        <a:font script="Telu" typeface="Gautami"/>
+        <a:font script="Taml" typeface="Latha"/>
+        <a:font script="Syrc" typeface="Estrangelo Edessa"/>
+        <a:font script="Orya" typeface="Kalinga"/>
+        <a:font script="Mlym" typeface="Kartika"/>
+        <a:font script="Laoo" typeface="DokChampa"/>
+        <a:font script="Sinh" typeface="Iskoola Pota"/>
+        <a:font script="Mong" typeface="Mongolian Baiti"/>
+        <a:font script="Viet" typeface="Times New Roman"/>
+        <a:font script="Uigh" typeface="Microsoft Uighur"/>
+        <a:font script="Geor" typeface="Sylfaen"/>
+        <a:font script="Armn" typeface="Arial"/>
+        <a:font script="Bugi" typeface="Leelawadee UI"/>
+        <a:font script="Bopo" typeface="Microsoft JhengHei"/>
+        <a:font script="Java" typeface="Javanese Text"/>
+        <a:font script="Lisu" typeface="Segoe UI"/>
+        <a:font script="Mymr" typeface="Myanmar Text"/>
+        <a:font script="Nkoo" typeface="Ebrima"/>
+        <a:font script="Olck" typeface="Nirmala UI"/>
+        <a:font script="Osma" typeface="Ebrima"/>
+        <a:font script="Phag" typeface="Phagspa"/>
+        <a:font script="Syrn" typeface="Estrangelo Edessa"/>
+        <a:font script="Syrj" typeface="Estrangelo Edessa"/>
+        <a:font script="Syre" typeface="Estrangelo Edessa"/>
+        <a:font script="Sora" typeface="Nirmala UI"/>
+        <a:font script="Tale" typeface="Microsoft Tai Le"/>
+        <a:font script="Talu" typeface="Microsoft New Tai Lue"/>
+        <a:font script="Tfng" typeface="Ebrima"/>
+      </a:majorFont>
+      <a:minorFont>
+        <a:latin typeface="Calibri" panose="020F0502020204030204"/>
+        <a:ea typeface=""/>
+        <a:cs typeface=""/>
+        <a:font script="Jpan" typeface="游ゴシック"/>
+        <a:font script="Hang" typeface="맑은 고딕"/>
+        <a:font script="Hans" typeface="等线"/>
+        <a:font script="Hant" typeface="新細明體"/>
+        <a:font script="Arab" typeface="Arial"/>
+        <a:font script="Hebr" typeface="Arial"/>
+        <a:font script="Thai" typeface="Cordia New"/>
+        <a:font script="Ethi" typeface="Nyala"/>
+        <a:font script="Beng" typeface="Vrinda"/>
+        <a:font script="Gujr" typeface="Shruti"/>
+        <a:font script="Khmr" typeface="DaunPenh"/>
+        <a:font script="Knda" typeface="Tunga"/>
+        <a:font script="Guru" typeface="Raavi"/>
+        <a:font script="Cans" typeface="Euphemia"/>
+        <a:font script="Cher" typeface="Plantagenet Cherokee"/>
+        <a:font script="Yiii" typeface="Microsoft Yi Baiti"/>
+        <a:font script="Tibt" typeface="Microsoft Himalaya"/>
+        <a:font script="Thaa" typeface="MV Boli"/>
+        <a:font script="Deva" typeface="Mangal"/>
+        <a:font script="Telu" typeface="Gautami"/>
+        <a:font script="Taml" typeface="Latha"/>
+        <a:font script="Syrc" typeface="Estrangelo Edessa"/>
+        <a:font script="Orya" typeface="Kalinga"/>
+        <a:font script="Mlym" typeface="Kartika"/>
+        <a:font script="Laoo" typeface="DokChampa"/>
+        <a:font script="Sinh" typeface="Iskoola Pota"/>
+        <a:font script="Mong" typeface="Mongolian Baiti"/>
+        <a:font script="Viet" typeface="Arial"/>
+        <a:font script="Uigh" typeface="Microsoft Uighur"/>
+        <a:font script="Geor" typeface="Sylfaen"/>
+        <a:font script="Armn" typeface="Arial"/>
+        <a:font script="Bugi" typeface="Leelawadee UI"/>
+        <a:font script="Bopo" typeface="Microsoft JhengHei"/>
+        <a:font script="Java" typeface="Javanese Text"/>
+        <a:font script="Lisu" typeface="Segoe UI"/>
+        <a:font script="Mymr" typeface="Myanmar Text"/>
+        <a:font script="Nkoo" typeface="Ebrima"/>
+        <a:font script="Olck" typeface="Nirmala UI"/>
+        <a:font script="Osma" typeface="Ebrima"/>
+        <a:font script="Phag" typeface="Phagspa"/>
+        <a:font script="Syrn" typeface="Estrangelo Edessa"/>
+        <a:font script="Syrj" typeface="Estrangelo Edessa"/>
+        <a:font script="Syre" typeface="Estrangelo Edessa"/>
+        <a:font script="Sora" typeface="Nirmala UI"/>
+        <a:font script="Tale" typeface="Microsoft Tai Le"/>
+        <a:font script="Talu" typeface="Microsoft New Tai Lue"/>
+        <a:font script="Tfng" typeface="Ebrima"/>
+      </a:minorFont>
+    </a:fontScheme>
+    <a:fmtScheme name="Office">
+      <a:fillStyleLst>
+        <a:solidFill>
+          <a:schemeClr val="phClr"/>
+        </a:solidFill>
+        <a:gradFill rotWithShape="1">
+          <a:gsLst>
+            <a:gs pos="0">
+              <a:schemeClr val="phClr">
+                <a:lumMod val="110000"/>
+                <a:satMod val="105000"/>
+                <a:tint val="67000"/>
+              </a:schemeClr>
+            </a:gs>
+            <a:gs pos="50000">
+              <a:schemeClr val="phClr">
+                <a:lumMod val="105000"/>
+                <a:satMod val="103000"/>
+                <a:tint val="73000"/>
+              </a:schemeClr>
+            </a:gs>
+            <a:gs pos="100000">
+              <a:schemeClr val="phClr">
+                <a:lumMod val="105000"/>
+                <a:satMod val="109000"/>
+                <a:tint val="81000"/>
+              </a:schemeClr>
+            </a:gs>
+          </a:gsLst>
+          <a:lin ang="5400000" scaled="0"/>
+        </a:gradFill>
+        <a:gradFill rotWithShape="1">
+          <a:gsLst>
+            <a:gs pos="0">
+              <a:schemeClr val="phClr">
+                <a:satMod val="103000"/>
+                <a:lumMod val="102000"/>
+                <a:tint val="94000"/>
+              </a:schemeClr>
+            </a:gs>
+            <a:gs pos="50000">
+              <a:schemeClr val="phClr">
+                <a:satMod val="110000"/>
+                <a:lumMod val="100000"/>
+                <a:shade val="100000"/>
+              </a:schemeClr>
+            </a:gs>
+            <a:gs pos="100000">
+              <a:schemeClr val="phClr">
+                <a:lumMod val="99000"/>
+                <a:satMod val="120000"/>
+                <a:shade val="78000"/>
+              </a:schemeClr>
+            </a:gs>
+          </a:gsLst>
+          <a:lin ang="5400000" scaled="0"/>
+        </a:gradFill>
+      </a:fillStyleLst>
+      <a:lnStyleLst>
+        <a:ln w="6350" cap="flat" cmpd="sng" algn="ctr">
+          <a:solidFill>
+            <a:schemeClr val="phClr"/>
+          </a:solidFill>
+          <a:prstDash val="solid"/>
+          <a:miter lim="800000"/>
+        </a:ln>
+        <a:ln w="12700" cap="flat" cmpd="sng" algn="ctr">
+          <a:solidFill>
+            <a:schemeClr val="phClr"/>
+          </a:solidFill>
+          <a:prstDash val="solid"/>
+          <a:miter lim="800000"/>
+        </a:ln>
+        <a:ln w="19050" cap="flat" cmpd="sng" algn="ctr">
+          <a:solidFill>
+            <a:schemeClr val="phClr"/>
+          </a:solidFill>
+          <a:prstDash val="solid"/>
+          <a:miter lim="800000"/>
+        </a:ln>
+      </a:lnStyleLst>
+      <a:effectStyleLst>
+        <a:effectStyle>
+          <a:effectLst/>
+        </a:effectStyle>
+        <a:effectStyle>
+          <a:effectLst/>
+        </a:effectStyle>
+        <a:effectStyle>
+          <a:effectLst>
+            <a:outerShdw blurRad="57150" dist="19050" dir="5400000" algn="ctr" rotWithShape="0">
+              <a:srgbClr val="000000">
+                <a:alpha val="63000"/>
+              </a:srgbClr>
+            </a:outerShdw>
+          </a:effectLst>
+        </a:effectStyle>
+      </a:effectStyleLst>
+      <a:bgFillStyleLst>
+        <a:solidFill>
+          <a:schemeClr val="phClr"/>
+        </a:solidFill>
+        <a:solidFill>
+          <a:schemeClr val="phClr">
+            <a:tint val="95000"/>
+            <a:satMod val="170000"/>
+          </a:schemeClr>
+        </a:solidFill>
+        <a:gradFill rotWithShape="1">
+          <a:gsLst>
+            <a:gs pos="0">
+              <a:schemeClr val="phClr">
+                <a:tint val="93000"/>
+                <a:satMod val="150000"/>
+                <a:shade val="98000"/>
+                <a:lumMod val="102000"/>
+              </a:schemeClr>
+            </a:gs>
+            <a:gs pos="50000">
+              <a:schemeClr val="phClr">
+                <a:tint val="98000"/>
+                <a:satMod val="130000"/>
+                <a:shade val="90000"/>
+                <a:lumMod val="103000"/>
+              </a:schemeClr>
+            </a:gs>
+            <a:gs pos="100000">
+              <a:schemeClr val="phClr">
+                <a:shade val="63000"/>
+                <a:satMod val="120000"/>
+              </a:schemeClr>
+            </a:gs>
+          </a:gsLst>
+          <a:lin ang="5400000" scaled="0"/>
+        </a:gradFill>
+      </a:bgFillStyleLst>
+    </a:fmtScheme>
+  </a:themeElements>
+  <a:objectDefaults/>
+  <a:extraClrSchemeLst/>
+  <a:extLst>
+    <a:ext uri="{05A4C25C-085E-4340-85A3-A5531E510DB2}">
+      <thm15:themeFamily xmlns:thm15="http://schemas.microsoft.com/office/thememl/2012/main" name="Office Theme" id="{62F939B6-93AF-4DB8-9C6B-D6C7DFDC589F}" vid="{4A3C46E8-61CC-4603-A589-7422A47A8E4A}"/>
+    </a:ext>
+  </a:extLst>
+</a:theme>
 </file>
</xml_diff>